<commit_message>
Deck: measure the text PowerPoint actually draws, not the boxes declared
The file-based checker reads declared rectangles, so a box declared 0.4in tall
that wraps to two lines passed as in-bounds and then spilled — which is what cut
the footer cards on the fleet slide.

deck/measure-deck.ps1 asks the renderer instead: TextRange.BoundHeight is the
height actually laid out. It flags text taller than its own box and text crossing
the bottom edge of the slide. It found three overflows the file-based check could
not see, on slides 5, 6 and 13.

Fixes: the fleet figure is narrower and therefore shorter, so the two tags below
it have a real bottom margin instead of sitting flush to the edge; the intro
paragraphs on 5 and 13 were one line short of the room they needed; and the two
tags now carry copy short enough to sit on one line each, so their baselines
agree.

Co-Authored-By: Claude Opus 5 <noreply@anthropic.com>
</commit_message>
<xml_diff>
--- a/deck/Aurora-Ops-Overview.pptx
+++ b/deck/Aurora-Ops-Overview.pptx
@@ -6204,7 +6204,7 @@
         <p:spPr>
           <a:xfrm>
             <a:off x="6419088" y="5394960"/>
-            <a:ext cx="4754880" cy="640080"/>
+            <a:ext cx="4754880" cy="731520"/>
           </a:xfrm>
           <a:prstGeom prst="rect">
             <a:avLst/>
@@ -10590,7 +10590,7 @@
         <p:spPr>
           <a:xfrm>
             <a:off x="566928" y="1664208"/>
-            <a:ext cx="10881360" cy="457200"/>
+            <a:ext cx="10881360" cy="566928"/>
           </a:xfrm>
           <a:prstGeom prst="rect">
             <a:avLst/>
@@ -10631,7 +10631,7 @@
         </p:nvSpPr>
         <p:spPr>
           <a:xfrm>
-            <a:off x="566928" y="2249424"/>
+            <a:off x="566928" y="2322576"/>
             <a:ext cx="3566160" cy="310896"/>
           </a:xfrm>
           <a:prstGeom prst="rect">
@@ -10684,7 +10684,7 @@
         </p:nvSpPr>
         <p:spPr>
           <a:xfrm>
-            <a:off x="4242816" y="2249424"/>
+            <a:off x="4242816" y="2322576"/>
             <a:ext cx="3566160" cy="310896"/>
           </a:xfrm>
           <a:prstGeom prst="rect">
@@ -10737,7 +10737,7 @@
         </p:nvSpPr>
         <p:spPr>
           <a:xfrm>
-            <a:off x="7918704" y="2249424"/>
+            <a:off x="7918704" y="2322576"/>
             <a:ext cx="3566160" cy="310896"/>
           </a:xfrm>
           <a:prstGeom prst="rect">
@@ -10790,8 +10790,8 @@
         </p:nvSpPr>
         <p:spPr>
           <a:xfrm>
-            <a:off x="1252728" y="2706624"/>
-            <a:ext cx="9692640" cy="3703479"/>
+            <a:off x="1252728" y="2743200"/>
+            <a:ext cx="9692640" cy="3520599"/>
           </a:xfrm>
           <a:prstGeom prst="rect">
             <a:avLst/>
@@ -10815,7 +10815,7 @@
         </p:nvSpPr>
         <p:spPr>
           <a:xfrm>
-            <a:off x="1252728" y="2706624"/>
+            <a:off x="1252728" y="2743200"/>
             <a:ext cx="9692640" cy="50292"/>
           </a:xfrm>
           <a:prstGeom prst="rect">
@@ -10848,7 +10848,7 @@
         </p:blipFill>
         <p:spPr>
           <a:xfrm>
-            <a:off x="1399032" y="2903220"/>
+            <a:off x="1399032" y="2939796"/>
             <a:ext cx="9400032" cy="2811939"/>
           </a:xfrm>
           <a:prstGeom prst="rect">
@@ -10864,7 +10864,7 @@
         </p:nvSpPr>
         <p:spPr>
           <a:xfrm>
-            <a:off x="1399032" y="5770023"/>
+            <a:off x="1399032" y="5806599"/>
             <a:ext cx="9400032" cy="237744"/>
           </a:xfrm>
           <a:prstGeom prst="rect">
@@ -10889,7 +10889,7 @@
                 <a:ea typeface="Arial" pitchFamily="34" charset="-122"/>
                 <a:cs typeface="Arial" pitchFamily="34" charset="-120"/>
               </a:rPr>
-              <a:t>THE CONSOLE — TALK ON THE LEFT, WATCH ON THE RIGHT</a:t>
+              <a:t>THE CONSOLE — TALK LEFT, WATCH RIGHT</a:t>
             </a:r>
             <a:endParaRPr lang="en-US" sz="900" dirty="0"/>
           </a:p>
@@ -11161,8 +11161,8 @@
         </p:nvSpPr>
         <p:spPr>
           <a:xfrm>
-            <a:off x="566928" y="2340864"/>
-            <a:ext cx="10881360" cy="3514222"/>
+            <a:off x="1344168" y="2340864"/>
+            <a:ext cx="9509760" cy="3150807"/>
           </a:xfrm>
           <a:prstGeom prst="rect">
             <a:avLst/>
@@ -11186,8 +11186,8 @@
         </p:nvSpPr>
         <p:spPr>
           <a:xfrm>
-            <a:off x="566928" y="2340864"/>
-            <a:ext cx="10881360" cy="50292"/>
+            <a:off x="1344168" y="2340864"/>
+            <a:ext cx="9509760" cy="50292"/>
           </a:xfrm>
           <a:prstGeom prst="rect">
             <a:avLst/>
@@ -11219,8 +11219,8 @@
         </p:blipFill>
         <p:spPr>
           <a:xfrm>
-            <a:off x="713232" y="2537460"/>
-            <a:ext cx="10588752" cy="2805562"/>
+            <a:off x="1490472" y="2537460"/>
+            <a:ext cx="9217152" cy="2442147"/>
           </a:xfrm>
           <a:prstGeom prst="rect">
             <a:avLst/>
@@ -11235,8 +11235,8 @@
         </p:nvSpPr>
         <p:spPr>
           <a:xfrm>
-            <a:off x="713232" y="5397886"/>
-            <a:ext cx="10588752" cy="237744"/>
+            <a:off x="1490472" y="5034471"/>
+            <a:ext cx="9217152" cy="237744"/>
           </a:xfrm>
           <a:prstGeom prst="rect">
             <a:avLst/>
@@ -11274,8 +11274,8 @@
         </p:nvSpPr>
         <p:spPr>
           <a:xfrm>
-            <a:off x="566928" y="6001390"/>
-            <a:ext cx="5340096" cy="841248"/>
+            <a:off x="566928" y="5729415"/>
+            <a:ext cx="5340096" cy="896112"/>
           </a:xfrm>
           <a:prstGeom prst="rect">
             <a:avLst/>
@@ -11299,7 +11299,7 @@
         </p:nvSpPr>
         <p:spPr>
           <a:xfrm>
-            <a:off x="859536" y="6165982"/>
+            <a:off x="859536" y="5894007"/>
             <a:ext cx="2194560" cy="219456"/>
           </a:xfrm>
           <a:prstGeom prst="rect">
@@ -11338,8 +11338,8 @@
         </p:nvSpPr>
         <p:spPr>
           <a:xfrm>
-            <a:off x="859536" y="6403726"/>
-            <a:ext cx="4754880" cy="365760"/>
+            <a:off x="859536" y="6131751"/>
+            <a:ext cx="4754880" cy="420624"/>
           </a:xfrm>
           <a:prstGeom prst="rect">
             <a:avLst/>
@@ -11383,7 +11383,7 @@
                 <a:ea typeface="Arial" pitchFamily="34" charset="-122"/>
                 <a:cs typeface="Arial" pitchFamily="34" charset="-120"/>
               </a:rPr>
-              <a:t>can read everything and change nothing</a:t>
+              <a:t>read everything, change nothing</a:t>
             </a:r>
             <a:endParaRPr lang="en-US" sz="1100" dirty="0"/>
           </a:p>
@@ -11397,8 +11397,8 @@
         </p:nvSpPr>
         <p:spPr>
           <a:xfrm>
-            <a:off x="6108192" y="6001390"/>
-            <a:ext cx="5340096" cy="841248"/>
+            <a:off x="6108192" y="5729415"/>
+            <a:ext cx="5340096" cy="896112"/>
           </a:xfrm>
           <a:prstGeom prst="rect">
             <a:avLst/>
@@ -11422,8 +11422,8 @@
         </p:nvSpPr>
         <p:spPr>
           <a:xfrm>
-            <a:off x="6108192" y="6001390"/>
-            <a:ext cx="54864" cy="841248"/>
+            <a:off x="6108192" y="5729415"/>
+            <a:ext cx="54864" cy="896112"/>
           </a:xfrm>
           <a:prstGeom prst="rect">
             <a:avLst/>
@@ -11447,7 +11447,7 @@
         </p:nvSpPr>
         <p:spPr>
           <a:xfrm>
-            <a:off x="6400800" y="6165982"/>
+            <a:off x="6400800" y="5894007"/>
             <a:ext cx="2194560" cy="219456"/>
           </a:xfrm>
           <a:prstGeom prst="rect">
@@ -11486,8 +11486,8 @@
         </p:nvSpPr>
         <p:spPr>
           <a:xfrm>
-            <a:off x="6400800" y="6403726"/>
-            <a:ext cx="4754880" cy="365760"/>
+            <a:off x="6400800" y="6131751"/>
+            <a:ext cx="4754880" cy="420624"/>
           </a:xfrm>
           <a:prstGeom prst="rect">
             <a:avLst/>
@@ -11531,7 +11531,7 @@
                 <a:ea typeface="Arial" pitchFamily="34" charset="-122"/>
                 <a:cs typeface="Arial" pitchFamily="34" charset="-120"/>
               </a:rPr>
-              <a:t>the only one able to alter anything — and only backups</a:t>
+              <a:t>the only one that can change anything</a:t>
             </a:r>
             <a:endParaRPr lang="en-US" sz="1100" dirty="0"/>
           </a:p>

</xml_diff>